<commit_message>
Update Calender Application Presentation file
</commit_message>
<xml_diff>
--- a/Calender Application Presentation.pptx
+++ b/Calender Application Presentation.pptx
@@ -4,10 +4,18 @@
   <p:sldMasterIdLst>
     <p:sldMasterId id="2147483672" r:id="rId1"/>
   </p:sldMasterIdLst>
+  <p:notesMasterIdLst>
+    <p:notesMasterId r:id="rId10"/>
+  </p:notesMasterIdLst>
   <p:sldIdLst>
     <p:sldId id="256" r:id="rId2"/>
-    <p:sldId id="257" r:id="rId3"/>
-    <p:sldId id="258" r:id="rId4"/>
+    <p:sldId id="265" r:id="rId3"/>
+    <p:sldId id="259" r:id="rId4"/>
+    <p:sldId id="261" r:id="rId5"/>
+    <p:sldId id="260" r:id="rId6"/>
+    <p:sldId id="262" r:id="rId7"/>
+    <p:sldId id="263" r:id="rId8"/>
+    <p:sldId id="264" r:id="rId9"/>
   </p:sldIdLst>
   <p:sldSz cx="12192000" cy="6858000"/>
   <p:notesSz cx="6858000" cy="9144000"/>
@@ -107,6 +115,526 @@
     </a:lvl9pPr>
   </p:defaultTextStyle>
 </p:presentation>
+</file>
+
+<file path=ppt/notesMasters/notesMaster1.xml><?xml version="1.0" encoding="utf-8"?>
+<p:notesMaster xmlns:a="http://schemas.openxmlformats.org/drawingml/2006/main" xmlns:r="http://schemas.openxmlformats.org/officeDocument/2006/relationships" xmlns:p="http://schemas.openxmlformats.org/presentationml/2006/main">
+  <p:cSld>
+    <p:bg>
+      <p:bgRef idx="1001">
+        <a:schemeClr val="bg1"/>
+      </p:bgRef>
+    </p:bg>
+    <p:spTree>
+      <p:nvGrpSpPr>
+        <p:cNvPr id="1" name=""/>
+        <p:cNvGrpSpPr/>
+        <p:nvPr/>
+      </p:nvGrpSpPr>
+      <p:grpSpPr>
+        <a:xfrm>
+          <a:off x="0" y="0"/>
+          <a:ext cx="0" cy="0"/>
+          <a:chOff x="0" y="0"/>
+          <a:chExt cx="0" cy="0"/>
+        </a:xfrm>
+      </p:grpSpPr>
+      <p:sp>
+        <p:nvSpPr>
+          <p:cNvPr id="2" name="Header Placeholder 1"/>
+          <p:cNvSpPr>
+            <a:spLocks noGrp="1"/>
+          </p:cNvSpPr>
+          <p:nvPr>
+            <p:ph type="hdr" sz="quarter"/>
+          </p:nvPr>
+        </p:nvSpPr>
+        <p:spPr>
+          <a:xfrm>
+            <a:off x="0" y="0"/>
+            <a:ext cx="2971800" cy="458788"/>
+          </a:xfrm>
+          <a:prstGeom prst="rect">
+            <a:avLst/>
+          </a:prstGeom>
+        </p:spPr>
+        <p:txBody>
+          <a:bodyPr vert="horz" lIns="91440" tIns="45720" rIns="91440" bIns="45720" rtlCol="0"/>
+          <a:lstStyle>
+            <a:lvl1pPr algn="l">
+              <a:defRPr sz="1200"/>
+            </a:lvl1pPr>
+          </a:lstStyle>
+          <a:p>
+            <a:endParaRPr lang="en-US"/>
+          </a:p>
+        </p:txBody>
+      </p:sp>
+      <p:sp>
+        <p:nvSpPr>
+          <p:cNvPr id="3" name="Date Placeholder 2"/>
+          <p:cNvSpPr>
+            <a:spLocks noGrp="1"/>
+          </p:cNvSpPr>
+          <p:nvPr>
+            <p:ph type="dt" idx="1"/>
+          </p:nvPr>
+        </p:nvSpPr>
+        <p:spPr>
+          <a:xfrm>
+            <a:off x="3884613" y="0"/>
+            <a:ext cx="2971800" cy="458788"/>
+          </a:xfrm>
+          <a:prstGeom prst="rect">
+            <a:avLst/>
+          </a:prstGeom>
+        </p:spPr>
+        <p:txBody>
+          <a:bodyPr vert="horz" lIns="91440" tIns="45720" rIns="91440" bIns="45720" rtlCol="0"/>
+          <a:lstStyle>
+            <a:lvl1pPr algn="r">
+              <a:defRPr sz="1200"/>
+            </a:lvl1pPr>
+          </a:lstStyle>
+          <a:p>
+            <a:fld id="{29524D0B-2C70-45B5-A49F-D7DEB3BE309B}" type="datetimeFigureOut">
+              <a:rPr lang="en-US" smtClean="0"/>
+              <a:t>6/11/2026</a:t>
+            </a:fld>
+            <a:endParaRPr lang="en-US"/>
+          </a:p>
+        </p:txBody>
+      </p:sp>
+      <p:sp>
+        <p:nvSpPr>
+          <p:cNvPr id="4" name="Slide Image Placeholder 3"/>
+          <p:cNvSpPr>
+            <a:spLocks noGrp="1" noRot="1" noChangeAspect="1"/>
+          </p:cNvSpPr>
+          <p:nvPr>
+            <p:ph type="sldImg" idx="2"/>
+          </p:nvPr>
+        </p:nvSpPr>
+        <p:spPr>
+          <a:xfrm>
+            <a:off x="685800" y="1143000"/>
+            <a:ext cx="5486400" cy="3086100"/>
+          </a:xfrm>
+          <a:prstGeom prst="rect">
+            <a:avLst/>
+          </a:prstGeom>
+          <a:noFill/>
+          <a:ln w="12700">
+            <a:solidFill>
+              <a:prstClr val="black"/>
+            </a:solidFill>
+          </a:ln>
+        </p:spPr>
+        <p:txBody>
+          <a:bodyPr vert="horz" lIns="91440" tIns="45720" rIns="91440" bIns="45720" rtlCol="0" anchor="ctr"/>
+          <a:lstStyle/>
+          <a:p>
+            <a:endParaRPr lang="en-US"/>
+          </a:p>
+        </p:txBody>
+      </p:sp>
+      <p:sp>
+        <p:nvSpPr>
+          <p:cNvPr id="5" name="Notes Placeholder 4"/>
+          <p:cNvSpPr>
+            <a:spLocks noGrp="1"/>
+          </p:cNvSpPr>
+          <p:nvPr>
+            <p:ph type="body" sz="quarter" idx="3"/>
+          </p:nvPr>
+        </p:nvSpPr>
+        <p:spPr>
+          <a:xfrm>
+            <a:off x="685800" y="4400550"/>
+            <a:ext cx="5486400" cy="3600450"/>
+          </a:xfrm>
+          <a:prstGeom prst="rect">
+            <a:avLst/>
+          </a:prstGeom>
+        </p:spPr>
+        <p:txBody>
+          <a:bodyPr vert="horz" lIns="91440" tIns="45720" rIns="91440" bIns="45720" rtlCol="0"/>
+          <a:lstStyle/>
+          <a:p>
+            <a:pPr lvl="0"/>
+            <a:r>
+              <a:rPr lang="en-US"/>
+              <a:t>Click to edit Master text styles</a:t>
+            </a:r>
+          </a:p>
+          <a:p>
+            <a:pPr lvl="1"/>
+            <a:r>
+              <a:rPr lang="en-US"/>
+              <a:t>Second level</a:t>
+            </a:r>
+          </a:p>
+          <a:p>
+            <a:pPr lvl="2"/>
+            <a:r>
+              <a:rPr lang="en-US"/>
+              <a:t>Third level</a:t>
+            </a:r>
+          </a:p>
+          <a:p>
+            <a:pPr lvl="3"/>
+            <a:r>
+              <a:rPr lang="en-US"/>
+              <a:t>Fourth level</a:t>
+            </a:r>
+          </a:p>
+          <a:p>
+            <a:pPr lvl="4"/>
+            <a:r>
+              <a:rPr lang="en-US"/>
+              <a:t>Fifth level</a:t>
+            </a:r>
+          </a:p>
+        </p:txBody>
+      </p:sp>
+      <p:sp>
+        <p:nvSpPr>
+          <p:cNvPr id="6" name="Footer Placeholder 5"/>
+          <p:cNvSpPr>
+            <a:spLocks noGrp="1"/>
+          </p:cNvSpPr>
+          <p:nvPr>
+            <p:ph type="ftr" sz="quarter" idx="4"/>
+          </p:nvPr>
+        </p:nvSpPr>
+        <p:spPr>
+          <a:xfrm>
+            <a:off x="0" y="8685213"/>
+            <a:ext cx="2971800" cy="458787"/>
+          </a:xfrm>
+          <a:prstGeom prst="rect">
+            <a:avLst/>
+          </a:prstGeom>
+        </p:spPr>
+        <p:txBody>
+          <a:bodyPr vert="horz" lIns="91440" tIns="45720" rIns="91440" bIns="45720" rtlCol="0" anchor="b"/>
+          <a:lstStyle>
+            <a:lvl1pPr algn="l">
+              <a:defRPr sz="1200"/>
+            </a:lvl1pPr>
+          </a:lstStyle>
+          <a:p>
+            <a:endParaRPr lang="en-US"/>
+          </a:p>
+        </p:txBody>
+      </p:sp>
+      <p:sp>
+        <p:nvSpPr>
+          <p:cNvPr id="7" name="Slide Number Placeholder 6"/>
+          <p:cNvSpPr>
+            <a:spLocks noGrp="1"/>
+          </p:cNvSpPr>
+          <p:nvPr>
+            <p:ph type="sldNum" sz="quarter" idx="5"/>
+          </p:nvPr>
+        </p:nvSpPr>
+        <p:spPr>
+          <a:xfrm>
+            <a:off x="3884613" y="8685213"/>
+            <a:ext cx="2971800" cy="458787"/>
+          </a:xfrm>
+          <a:prstGeom prst="rect">
+            <a:avLst/>
+          </a:prstGeom>
+        </p:spPr>
+        <p:txBody>
+          <a:bodyPr vert="horz" lIns="91440" tIns="45720" rIns="91440" bIns="45720" rtlCol="0" anchor="b"/>
+          <a:lstStyle>
+            <a:lvl1pPr algn="r">
+              <a:defRPr sz="1200"/>
+            </a:lvl1pPr>
+          </a:lstStyle>
+          <a:p>
+            <a:fld id="{BD489ED0-11FC-40EE-80EF-AB0F97504AD2}" type="slidenum">
+              <a:rPr lang="en-US" smtClean="0"/>
+              <a:t>‹#›</a:t>
+            </a:fld>
+            <a:endParaRPr lang="en-US"/>
+          </a:p>
+        </p:txBody>
+      </p:sp>
+    </p:spTree>
+    <p:extLst>
+      <p:ext uri="{BB962C8B-B14F-4D97-AF65-F5344CB8AC3E}">
+        <p14:creationId xmlns:p14="http://schemas.microsoft.com/office/powerpoint/2010/main" val="2746042533"/>
+      </p:ext>
+    </p:extLst>
+  </p:cSld>
+  <p:clrMap bg1="lt1" tx1="dk1" bg2="lt2" tx2="dk2" accent1="accent1" accent2="accent2" accent3="accent3" accent4="accent4" accent5="accent5" accent6="accent6" hlink="hlink" folHlink="folHlink"/>
+  <p:notesStyle>
+    <a:lvl1pPr marL="0" algn="l" defTabSz="914400" rtl="0" eaLnBrk="1" latinLnBrk="0" hangingPunct="1">
+      <a:defRPr sz="1200" kern="1200">
+        <a:solidFill>
+          <a:schemeClr val="tx1"/>
+        </a:solidFill>
+        <a:latin typeface="+mn-lt"/>
+        <a:ea typeface="+mn-ea"/>
+        <a:cs typeface="+mn-cs"/>
+      </a:defRPr>
+    </a:lvl1pPr>
+    <a:lvl2pPr marL="457200" algn="l" defTabSz="914400" rtl="0" eaLnBrk="1" latinLnBrk="0" hangingPunct="1">
+      <a:defRPr sz="1200" kern="1200">
+        <a:solidFill>
+          <a:schemeClr val="tx1"/>
+        </a:solidFill>
+        <a:latin typeface="+mn-lt"/>
+        <a:ea typeface="+mn-ea"/>
+        <a:cs typeface="+mn-cs"/>
+      </a:defRPr>
+    </a:lvl2pPr>
+    <a:lvl3pPr marL="914400" algn="l" defTabSz="914400" rtl="0" eaLnBrk="1" latinLnBrk="0" hangingPunct="1">
+      <a:defRPr sz="1200" kern="1200">
+        <a:solidFill>
+          <a:schemeClr val="tx1"/>
+        </a:solidFill>
+        <a:latin typeface="+mn-lt"/>
+        <a:ea typeface="+mn-ea"/>
+        <a:cs typeface="+mn-cs"/>
+      </a:defRPr>
+    </a:lvl3pPr>
+    <a:lvl4pPr marL="1371600" algn="l" defTabSz="914400" rtl="0" eaLnBrk="1" latinLnBrk="0" hangingPunct="1">
+      <a:defRPr sz="1200" kern="1200">
+        <a:solidFill>
+          <a:schemeClr val="tx1"/>
+        </a:solidFill>
+        <a:latin typeface="+mn-lt"/>
+        <a:ea typeface="+mn-ea"/>
+        <a:cs typeface="+mn-cs"/>
+      </a:defRPr>
+    </a:lvl4pPr>
+    <a:lvl5pPr marL="1828800" algn="l" defTabSz="914400" rtl="0" eaLnBrk="1" latinLnBrk="0" hangingPunct="1">
+      <a:defRPr sz="1200" kern="1200">
+        <a:solidFill>
+          <a:schemeClr val="tx1"/>
+        </a:solidFill>
+        <a:latin typeface="+mn-lt"/>
+        <a:ea typeface="+mn-ea"/>
+        <a:cs typeface="+mn-cs"/>
+      </a:defRPr>
+    </a:lvl5pPr>
+    <a:lvl6pPr marL="2286000" algn="l" defTabSz="914400" rtl="0" eaLnBrk="1" latinLnBrk="0" hangingPunct="1">
+      <a:defRPr sz="1200" kern="1200">
+        <a:solidFill>
+          <a:schemeClr val="tx1"/>
+        </a:solidFill>
+        <a:latin typeface="+mn-lt"/>
+        <a:ea typeface="+mn-ea"/>
+        <a:cs typeface="+mn-cs"/>
+      </a:defRPr>
+    </a:lvl6pPr>
+    <a:lvl7pPr marL="2743200" algn="l" defTabSz="914400" rtl="0" eaLnBrk="1" latinLnBrk="0" hangingPunct="1">
+      <a:defRPr sz="1200" kern="1200">
+        <a:solidFill>
+          <a:schemeClr val="tx1"/>
+        </a:solidFill>
+        <a:latin typeface="+mn-lt"/>
+        <a:ea typeface="+mn-ea"/>
+        <a:cs typeface="+mn-cs"/>
+      </a:defRPr>
+    </a:lvl7pPr>
+    <a:lvl8pPr marL="3200400" algn="l" defTabSz="914400" rtl="0" eaLnBrk="1" latinLnBrk="0" hangingPunct="1">
+      <a:defRPr sz="1200" kern="1200">
+        <a:solidFill>
+          <a:schemeClr val="tx1"/>
+        </a:solidFill>
+        <a:latin typeface="+mn-lt"/>
+        <a:ea typeface="+mn-ea"/>
+        <a:cs typeface="+mn-cs"/>
+      </a:defRPr>
+    </a:lvl8pPr>
+    <a:lvl9pPr marL="3657600" algn="l" defTabSz="914400" rtl="0" eaLnBrk="1" latinLnBrk="0" hangingPunct="1">
+      <a:defRPr sz="1200" kern="1200">
+        <a:solidFill>
+          <a:schemeClr val="tx1"/>
+        </a:solidFill>
+        <a:latin typeface="+mn-lt"/>
+        <a:ea typeface="+mn-ea"/>
+        <a:cs typeface="+mn-cs"/>
+      </a:defRPr>
+    </a:lvl9pPr>
+  </p:notesStyle>
+</p:notesMaster>
+</file>
+
+<file path=ppt/notesSlides/notesSlide1.xml><?xml version="1.0" encoding="utf-8"?>
+<p:notes xmlns:a="http://schemas.openxmlformats.org/drawingml/2006/main" xmlns:r="http://schemas.openxmlformats.org/officeDocument/2006/relationships" xmlns:p="http://schemas.openxmlformats.org/presentationml/2006/main">
+  <p:cSld>
+    <p:spTree>
+      <p:nvGrpSpPr>
+        <p:cNvPr id="1" name=""/>
+        <p:cNvGrpSpPr/>
+        <p:nvPr/>
+      </p:nvGrpSpPr>
+      <p:grpSpPr>
+        <a:xfrm>
+          <a:off x="0" y="0"/>
+          <a:ext cx="0" cy="0"/>
+          <a:chOff x="0" y="0"/>
+          <a:chExt cx="0" cy="0"/>
+        </a:xfrm>
+      </p:grpSpPr>
+      <p:sp>
+        <p:nvSpPr>
+          <p:cNvPr id="2" name="Slide Image Placeholder 1"/>
+          <p:cNvSpPr>
+            <a:spLocks noGrp="1" noRot="1" noChangeAspect="1"/>
+          </p:cNvSpPr>
+          <p:nvPr>
+            <p:ph type="sldImg"/>
+          </p:nvPr>
+        </p:nvSpPr>
+        <p:spPr/>
+      </p:sp>
+      <p:sp>
+        <p:nvSpPr>
+          <p:cNvPr id="3" name="Notes Placeholder 2"/>
+          <p:cNvSpPr>
+            <a:spLocks noGrp="1"/>
+          </p:cNvSpPr>
+          <p:nvPr>
+            <p:ph type="body" idx="1"/>
+          </p:nvPr>
+        </p:nvSpPr>
+        <p:spPr/>
+        <p:txBody>
+          <a:bodyPr/>
+          <a:lstStyle/>
+          <a:p>
+            <a:r>
+              <a:rPr lang="en-US" dirty="0"/>
+              <a:t>Mention how the logic for finding the next possible time slot proved more challenging than expected</a:t>
+            </a:r>
+          </a:p>
+        </p:txBody>
+      </p:sp>
+      <p:sp>
+        <p:nvSpPr>
+          <p:cNvPr id="4" name="Slide Number Placeholder 3"/>
+          <p:cNvSpPr>
+            <a:spLocks noGrp="1"/>
+          </p:cNvSpPr>
+          <p:nvPr>
+            <p:ph type="sldNum" sz="quarter" idx="5"/>
+          </p:nvPr>
+        </p:nvSpPr>
+        <p:spPr/>
+        <p:txBody>
+          <a:bodyPr/>
+          <a:lstStyle/>
+          <a:p>
+            <a:fld id="{BD489ED0-11FC-40EE-80EF-AB0F97504AD2}" type="slidenum">
+              <a:rPr lang="en-US" smtClean="0"/>
+              <a:t>2</a:t>
+            </a:fld>
+            <a:endParaRPr lang="en-US"/>
+          </a:p>
+        </p:txBody>
+      </p:sp>
+    </p:spTree>
+    <p:extLst>
+      <p:ext uri="{BB962C8B-B14F-4D97-AF65-F5344CB8AC3E}">
+        <p14:creationId xmlns:p14="http://schemas.microsoft.com/office/powerpoint/2010/main" val="4117155089"/>
+      </p:ext>
+    </p:extLst>
+  </p:cSld>
+  <p:clrMapOvr>
+    <a:masterClrMapping/>
+  </p:clrMapOvr>
+</p:notes>
+</file>
+
+<file path=ppt/notesSlides/notesSlide2.xml><?xml version="1.0" encoding="utf-8"?>
+<p:notes xmlns:a="http://schemas.openxmlformats.org/drawingml/2006/main" xmlns:r="http://schemas.openxmlformats.org/officeDocument/2006/relationships" xmlns:p="http://schemas.openxmlformats.org/presentationml/2006/main">
+  <p:cSld>
+    <p:spTree>
+      <p:nvGrpSpPr>
+        <p:cNvPr id="1" name=""/>
+        <p:cNvGrpSpPr/>
+        <p:nvPr/>
+      </p:nvGrpSpPr>
+      <p:grpSpPr>
+        <a:xfrm>
+          <a:off x="0" y="0"/>
+          <a:ext cx="0" cy="0"/>
+          <a:chOff x="0" y="0"/>
+          <a:chExt cx="0" cy="0"/>
+        </a:xfrm>
+      </p:grpSpPr>
+      <p:sp>
+        <p:nvSpPr>
+          <p:cNvPr id="2" name="Slide Image Placeholder 1"/>
+          <p:cNvSpPr>
+            <a:spLocks noGrp="1" noRot="1" noChangeAspect="1"/>
+          </p:cNvSpPr>
+          <p:nvPr>
+            <p:ph type="sldImg"/>
+          </p:nvPr>
+        </p:nvSpPr>
+        <p:spPr/>
+      </p:sp>
+      <p:sp>
+        <p:nvSpPr>
+          <p:cNvPr id="3" name="Notes Placeholder 2"/>
+          <p:cNvSpPr>
+            <a:spLocks noGrp="1"/>
+          </p:cNvSpPr>
+          <p:nvPr>
+            <p:ph type="body" idx="1"/>
+          </p:nvPr>
+        </p:nvSpPr>
+        <p:spPr/>
+        <p:txBody>
+          <a:bodyPr/>
+          <a:lstStyle/>
+          <a:p>
+            <a:endParaRPr lang="en-US" dirty="0"/>
+          </a:p>
+        </p:txBody>
+      </p:sp>
+      <p:sp>
+        <p:nvSpPr>
+          <p:cNvPr id="4" name="Slide Number Placeholder 3"/>
+          <p:cNvSpPr>
+            <a:spLocks noGrp="1"/>
+          </p:cNvSpPr>
+          <p:nvPr>
+            <p:ph type="sldNum" sz="quarter" idx="5"/>
+          </p:nvPr>
+        </p:nvSpPr>
+        <p:spPr/>
+        <p:txBody>
+          <a:bodyPr/>
+          <a:lstStyle/>
+          <a:p>
+            <a:fld id="{BD489ED0-11FC-40EE-80EF-AB0F97504AD2}" type="slidenum">
+              <a:rPr lang="en-US" smtClean="0"/>
+              <a:t>5</a:t>
+            </a:fld>
+            <a:endParaRPr lang="en-US"/>
+          </a:p>
+        </p:txBody>
+      </p:sp>
+    </p:spTree>
+    <p:extLst>
+      <p:ext uri="{BB962C8B-B14F-4D97-AF65-F5344CB8AC3E}">
+        <p14:creationId xmlns:p14="http://schemas.microsoft.com/office/powerpoint/2010/main" val="148799027"/>
+      </p:ext>
+    </p:extLst>
+  </p:cSld>
+  <p:clrMapOvr>
+    <a:masterClrMapping/>
+  </p:clrMapOvr>
+</p:notes>
 </file>
 
 <file path=ppt/slideLayouts/slideLayout1.xml><?xml version="1.0" encoding="utf-8"?>
@@ -6231,7 +6759,7 @@
           <p:cNvPr id="2" name="Title 1">
             <a:extLst>
               <a:ext uri="{FF2B5EF4-FFF2-40B4-BE49-F238E27FC236}">
-                <a16:creationId xmlns:a16="http://schemas.microsoft.com/office/drawing/2014/main" id="{0AA5FC5D-115B-B625-2C54-65A7237258E5}"/>
+                <a16:creationId xmlns:a16="http://schemas.microsoft.com/office/drawing/2014/main" id="{46D23AE0-F98D-57B5-9111-1973F1E1874D}"/>
               </a:ext>
             </a:extLst>
           </p:cNvPr>
@@ -6249,7 +6777,7 @@
           <a:p>
             <a:r>
               <a:rPr lang="en-US" dirty="0"/>
-              <a:t>Overview</a:t>
+              <a:t>Approach &amp; Desing</a:t>
             </a:r>
           </a:p>
         </p:txBody>
@@ -6259,7 +6787,7 @@
           <p:cNvPr id="3" name="Content Placeholder 2">
             <a:extLst>
               <a:ext uri="{FF2B5EF4-FFF2-40B4-BE49-F238E27FC236}">
-                <a16:creationId xmlns:a16="http://schemas.microsoft.com/office/drawing/2014/main" id="{54EB5F89-5D8A-7CE7-36C3-FC6F82A8A16A}"/>
+                <a16:creationId xmlns:a16="http://schemas.microsoft.com/office/drawing/2014/main" id="{57B21049-FE0A-ECBA-3E1E-6712932FB90B}"/>
               </a:ext>
             </a:extLst>
           </p:cNvPr>
@@ -6277,33 +6805,44 @@
           <a:p>
             <a:r>
               <a:rPr lang="en-US" dirty="0"/>
-              <a:t>Command Line Management Application in java</a:t>
+              <a:t>Create a CLI Calander management application</a:t>
             </a:r>
           </a:p>
           <a:p>
             <a:r>
               <a:rPr lang="en-US" dirty="0"/>
-              <a:t>Create </a:t>
+              <a:t>Focus on days to encapsulate events for easy access</a:t>
             </a:r>
           </a:p>
           <a:p>
             <a:r>
               <a:rPr lang="en-US" dirty="0"/>
-              <a:t>Manage</a:t>
+              <a:t>Events are stored in a day, Days are stored in a Month</a:t>
             </a:r>
           </a:p>
           <a:p>
             <a:r>
               <a:rPr lang="en-US" dirty="0"/>
-              <a:t>Organize</a:t>
-            </a:r>
+              <a:t>User interaction is managed with the </a:t>
+            </a:r>
+            <a:r>
+              <a:rPr lang="en-US" dirty="0" err="1"/>
+              <a:t>CommandInterface</a:t>
+            </a:r>
+            <a:r>
+              <a:rPr lang="en-US" dirty="0"/>
+              <a:t> Class</a:t>
+            </a:r>
+          </a:p>
+          <a:p>
+            <a:endParaRPr lang="en-US" dirty="0"/>
           </a:p>
         </p:txBody>
       </p:sp>
     </p:spTree>
     <p:extLst>
       <p:ext uri="{BB962C8B-B14F-4D97-AF65-F5344CB8AC3E}">
-        <p14:creationId xmlns:p14="http://schemas.microsoft.com/office/powerpoint/2010/main" val="2025083591"/>
+        <p14:creationId xmlns:p14="http://schemas.microsoft.com/office/powerpoint/2010/main" val="84385830"/>
       </p:ext>
     </p:extLst>
   </p:cSld>
@@ -6335,7 +6874,7 @@
           <p:cNvPr id="2" name="Title 1">
             <a:extLst>
               <a:ext uri="{FF2B5EF4-FFF2-40B4-BE49-F238E27FC236}">
-                <a16:creationId xmlns:a16="http://schemas.microsoft.com/office/drawing/2014/main" id="{3265C2DF-1F98-58C8-9517-020E0D4388CA}"/>
+                <a16:creationId xmlns:a16="http://schemas.microsoft.com/office/drawing/2014/main" id="{C1DF1BFF-3F70-44D6-1295-18F02D42C382}"/>
               </a:ext>
             </a:extLst>
           </p:cNvPr>
@@ -6353,7 +6892,7 @@
           <a:p>
             <a:r>
               <a:rPr lang="en-US" dirty="0"/>
-              <a:t>Approach and Desing</a:t>
+              <a:t>Key Features</a:t>
             </a:r>
           </a:p>
         </p:txBody>
@@ -6363,7 +6902,7 @@
           <p:cNvPr id="3" name="Content Placeholder 2">
             <a:extLst>
               <a:ext uri="{FF2B5EF4-FFF2-40B4-BE49-F238E27FC236}">
-                <a16:creationId xmlns:a16="http://schemas.microsoft.com/office/drawing/2014/main" id="{BD083ECB-6175-817B-9A04-04453E1EB122}"/>
+                <a16:creationId xmlns:a16="http://schemas.microsoft.com/office/drawing/2014/main" id="{9FC4DB28-8AC0-7072-C91A-5884950C06FF}"/>
               </a:ext>
             </a:extLst>
           </p:cNvPr>
@@ -6381,22 +6920,812 @@
           <a:p>
             <a:r>
               <a:rPr lang="en-US" dirty="0"/>
-              <a:t>Object </a:t>
-            </a:r>
-            <a:r>
-              <a:rPr lang="en-US"/>
-              <a:t>Orientated Desing</a:t>
-            </a:r>
-          </a:p>
-          <a:p>
-            <a:endParaRPr lang="en-US"/>
-          </a:p>
-        </p:txBody>
-      </p:sp>
+              <a:t>View days and event counts</a:t>
+            </a:r>
+          </a:p>
+          <a:p>
+            <a:r>
+              <a:rPr lang="en-US" dirty="0"/>
+              <a:t>View all events for each day</a:t>
+            </a:r>
+          </a:p>
+          <a:p>
+            <a:r>
+              <a:rPr lang="en-US" dirty="0"/>
+              <a:t>Add, remove and modify any event</a:t>
+            </a:r>
+          </a:p>
+          <a:p>
+            <a:r>
+              <a:rPr lang="en-US" dirty="0"/>
+              <a:t>Avoid schedule conflicts</a:t>
+            </a:r>
+          </a:p>
+          <a:p>
+            <a:r>
+              <a:rPr lang="en-US" dirty="0"/>
+              <a:t>Find available time slots</a:t>
+            </a:r>
+          </a:p>
+          <a:p>
+            <a:r>
+              <a:rPr lang="en-US" dirty="0"/>
+              <a:t>Input validation</a:t>
+            </a:r>
+          </a:p>
+        </p:txBody>
+      </p:sp>
+      <p:pic>
+        <p:nvPicPr>
+          <p:cNvPr id="5" name="Picture 4">
+            <a:extLst>
+              <a:ext uri="{FF2B5EF4-FFF2-40B4-BE49-F238E27FC236}">
+                <a16:creationId xmlns:a16="http://schemas.microsoft.com/office/drawing/2014/main" id="{BF4774E1-8BA7-C035-BF2C-B56DC27330F4}"/>
+              </a:ext>
+            </a:extLst>
+          </p:cNvPr>
+          <p:cNvPicPr>
+            <a:picLocks noChangeAspect="1"/>
+          </p:cNvPicPr>
+          <p:nvPr/>
+        </p:nvPicPr>
+        <p:blipFill>
+          <a:blip r:embed="rId2"/>
+          <a:stretch>
+            <a:fillRect/>
+          </a:stretch>
+        </p:blipFill>
+        <p:spPr>
+          <a:xfrm>
+            <a:off x="8264071" y="2438399"/>
+            <a:ext cx="3238952" cy="3172268"/>
+          </a:xfrm>
+          <a:prstGeom prst="rect">
+            <a:avLst/>
+          </a:prstGeom>
+        </p:spPr>
+      </p:pic>
     </p:spTree>
     <p:extLst>
       <p:ext uri="{BB962C8B-B14F-4D97-AF65-F5344CB8AC3E}">
-        <p14:creationId xmlns:p14="http://schemas.microsoft.com/office/powerpoint/2010/main" val="3322540191"/>
+        <p14:creationId xmlns:p14="http://schemas.microsoft.com/office/powerpoint/2010/main" val="2361601701"/>
+      </p:ext>
+    </p:extLst>
+  </p:cSld>
+  <p:clrMapOvr>
+    <a:masterClrMapping/>
+  </p:clrMapOvr>
+</p:sld>
+</file>
+
+<file path=ppt/slides/slide4.xml><?xml version="1.0" encoding="utf-8"?>
+<p:sld xmlns:a="http://schemas.openxmlformats.org/drawingml/2006/main" xmlns:r="http://schemas.openxmlformats.org/officeDocument/2006/relationships" xmlns:p="http://schemas.openxmlformats.org/presentationml/2006/main">
+  <p:cSld>
+    <p:spTree>
+      <p:nvGrpSpPr>
+        <p:cNvPr id="1" name=""/>
+        <p:cNvGrpSpPr/>
+        <p:nvPr/>
+      </p:nvGrpSpPr>
+      <p:grpSpPr>
+        <a:xfrm>
+          <a:off x="0" y="0"/>
+          <a:ext cx="0" cy="0"/>
+          <a:chOff x="0" y="0"/>
+          <a:chExt cx="0" cy="0"/>
+        </a:xfrm>
+      </p:grpSpPr>
+      <p:sp>
+        <p:nvSpPr>
+          <p:cNvPr id="2" name="Title 1">
+            <a:extLst>
+              <a:ext uri="{FF2B5EF4-FFF2-40B4-BE49-F238E27FC236}">
+                <a16:creationId xmlns:a16="http://schemas.microsoft.com/office/drawing/2014/main" id="{C8014A08-CECE-75AB-A54C-578F386BCBCD}"/>
+              </a:ext>
+            </a:extLst>
+          </p:cNvPr>
+          <p:cNvSpPr>
+            <a:spLocks noGrp="1"/>
+          </p:cNvSpPr>
+          <p:nvPr>
+            <p:ph type="title"/>
+          </p:nvPr>
+        </p:nvSpPr>
+        <p:spPr/>
+        <p:txBody>
+          <a:bodyPr/>
+          <a:lstStyle/>
+          <a:p>
+            <a:r>
+              <a:rPr lang="en-US" dirty="0"/>
+              <a:t>Conflict detection</a:t>
+            </a:r>
+          </a:p>
+        </p:txBody>
+      </p:sp>
+      <p:sp>
+        <p:nvSpPr>
+          <p:cNvPr id="3" name="Content Placeholder 2">
+            <a:extLst>
+              <a:ext uri="{FF2B5EF4-FFF2-40B4-BE49-F238E27FC236}">
+                <a16:creationId xmlns:a16="http://schemas.microsoft.com/office/drawing/2014/main" id="{A287FC95-C97F-D096-3B5B-A5D6E6DD5E54}"/>
+              </a:ext>
+            </a:extLst>
+          </p:cNvPr>
+          <p:cNvSpPr>
+            <a:spLocks noGrp="1"/>
+          </p:cNvSpPr>
+          <p:nvPr>
+            <p:ph idx="1"/>
+          </p:nvPr>
+        </p:nvSpPr>
+        <p:spPr/>
+        <p:txBody>
+          <a:bodyPr/>
+          <a:lstStyle/>
+          <a:p>
+            <a:r>
+              <a:rPr lang="en-US" dirty="0"/>
+              <a:t>prevent overlapping events from being scheduled</a:t>
+            </a:r>
+          </a:p>
+          <a:p>
+            <a:r>
+              <a:rPr lang="en-US" dirty="0"/>
+              <a:t> If a conflict is detected, the user is prompted to enter a different time.</a:t>
+            </a:r>
+          </a:p>
+          <a:p>
+            <a:r>
+              <a:rPr lang="en-US" dirty="0"/>
+              <a:t>Also avoids conflicts when modifying start time and end times for events</a:t>
+            </a:r>
+          </a:p>
+        </p:txBody>
+      </p:sp>
+      <p:pic>
+        <p:nvPicPr>
+          <p:cNvPr id="5" name="Picture 4">
+            <a:extLst>
+              <a:ext uri="{FF2B5EF4-FFF2-40B4-BE49-F238E27FC236}">
+                <a16:creationId xmlns:a16="http://schemas.microsoft.com/office/drawing/2014/main" id="{3045B572-AC0B-EFCD-7A0D-7E69A3B385E1}"/>
+              </a:ext>
+            </a:extLst>
+          </p:cNvPr>
+          <p:cNvPicPr>
+            <a:picLocks noChangeAspect="1"/>
+          </p:cNvPicPr>
+          <p:nvPr/>
+        </p:nvPicPr>
+        <p:blipFill>
+          <a:blip r:embed="rId2"/>
+          <a:stretch>
+            <a:fillRect/>
+          </a:stretch>
+        </p:blipFill>
+        <p:spPr>
+          <a:xfrm>
+            <a:off x="3705072" y="5097777"/>
+            <a:ext cx="8249801" cy="1552792"/>
+          </a:xfrm>
+          <a:prstGeom prst="rect">
+            <a:avLst/>
+          </a:prstGeom>
+        </p:spPr>
+      </p:pic>
+    </p:spTree>
+    <p:extLst>
+      <p:ext uri="{BB962C8B-B14F-4D97-AF65-F5344CB8AC3E}">
+        <p14:creationId xmlns:p14="http://schemas.microsoft.com/office/powerpoint/2010/main" val="1408684110"/>
+      </p:ext>
+    </p:extLst>
+  </p:cSld>
+  <p:clrMapOvr>
+    <a:masterClrMapping/>
+  </p:clrMapOvr>
+</p:sld>
+</file>
+
+<file path=ppt/slides/slide5.xml><?xml version="1.0" encoding="utf-8"?>
+<p:sld xmlns:a="http://schemas.openxmlformats.org/drawingml/2006/main" xmlns:r="http://schemas.openxmlformats.org/officeDocument/2006/relationships" xmlns:p="http://schemas.openxmlformats.org/presentationml/2006/main">
+  <p:cSld>
+    <p:spTree>
+      <p:nvGrpSpPr>
+        <p:cNvPr id="1" name=""/>
+        <p:cNvGrpSpPr/>
+        <p:nvPr/>
+      </p:nvGrpSpPr>
+      <p:grpSpPr>
+        <a:xfrm>
+          <a:off x="0" y="0"/>
+          <a:ext cx="0" cy="0"/>
+          <a:chOff x="0" y="0"/>
+          <a:chExt cx="0" cy="0"/>
+        </a:xfrm>
+      </p:grpSpPr>
+      <p:sp>
+        <p:nvSpPr>
+          <p:cNvPr id="2" name="Title 1">
+            <a:extLst>
+              <a:ext uri="{FF2B5EF4-FFF2-40B4-BE49-F238E27FC236}">
+                <a16:creationId xmlns:a16="http://schemas.microsoft.com/office/drawing/2014/main" id="{E8F9045C-EB1F-7D4D-C60B-160E3C885103}"/>
+              </a:ext>
+            </a:extLst>
+          </p:cNvPr>
+          <p:cNvSpPr>
+            <a:spLocks noGrp="1"/>
+          </p:cNvSpPr>
+          <p:nvPr>
+            <p:ph type="title"/>
+          </p:nvPr>
+        </p:nvSpPr>
+        <p:spPr/>
+        <p:txBody>
+          <a:bodyPr/>
+          <a:lstStyle/>
+          <a:p>
+            <a:r>
+              <a:rPr lang="en-US" dirty="0"/>
+              <a:t>How to run</a:t>
+            </a:r>
+          </a:p>
+        </p:txBody>
+      </p:sp>
+      <p:sp>
+        <p:nvSpPr>
+          <p:cNvPr id="3" name="Content Placeholder 2">
+            <a:extLst>
+              <a:ext uri="{FF2B5EF4-FFF2-40B4-BE49-F238E27FC236}">
+                <a16:creationId xmlns:a16="http://schemas.microsoft.com/office/drawing/2014/main" id="{B6DD9937-62EA-F2B4-EB87-C66C7F06729C}"/>
+              </a:ext>
+            </a:extLst>
+          </p:cNvPr>
+          <p:cNvSpPr>
+            <a:spLocks noGrp="1"/>
+          </p:cNvSpPr>
+          <p:nvPr>
+            <p:ph idx="1"/>
+          </p:nvPr>
+        </p:nvSpPr>
+        <p:spPr/>
+        <p:txBody>
+          <a:bodyPr/>
+          <a:lstStyle/>
+          <a:p>
+            <a:r>
+              <a:rPr lang="en-US" b="1" dirty="0"/>
+              <a:t>Compile</a:t>
+            </a:r>
+          </a:p>
+          <a:p>
+            <a:pPr marL="0" indent="0">
+              <a:buNone/>
+            </a:pPr>
+            <a:r>
+              <a:rPr lang="en-US" dirty="0" err="1"/>
+              <a:t>javac</a:t>
+            </a:r>
+            <a:r>
+              <a:rPr lang="en-US" dirty="0"/>
+              <a:t> .\</a:t>
+            </a:r>
+            <a:r>
+              <a:rPr lang="en-US" dirty="0" err="1"/>
+              <a:t>src</a:t>
+            </a:r>
+            <a:r>
+              <a:rPr lang="en-US" dirty="0"/>
+              <a:t>\*.java</a:t>
+            </a:r>
+          </a:p>
+          <a:p>
+            <a:r>
+              <a:rPr lang="en-US" b="1" dirty="0"/>
+              <a:t>run</a:t>
+            </a:r>
+          </a:p>
+          <a:p>
+            <a:pPr marL="0" indent="0">
+              <a:buNone/>
+            </a:pPr>
+            <a:r>
+              <a:rPr lang="en-US" dirty="0"/>
+              <a:t>java .\</a:t>
+            </a:r>
+            <a:r>
+              <a:rPr lang="en-US" dirty="0" err="1"/>
+              <a:t>src</a:t>
+            </a:r>
+            <a:r>
+              <a:rPr lang="en-US" dirty="0"/>
+              <a:t>\CommandInterface.java</a:t>
+            </a:r>
+          </a:p>
+          <a:p>
+            <a:endParaRPr lang="en-US" dirty="0"/>
+          </a:p>
+        </p:txBody>
+      </p:sp>
+      <p:pic>
+        <p:nvPicPr>
+          <p:cNvPr id="5" name="Picture 4">
+            <a:extLst>
+              <a:ext uri="{FF2B5EF4-FFF2-40B4-BE49-F238E27FC236}">
+                <a16:creationId xmlns:a16="http://schemas.microsoft.com/office/drawing/2014/main" id="{112CB8AE-EA9B-3859-E7B1-987EC92B30DB}"/>
+              </a:ext>
+            </a:extLst>
+          </p:cNvPr>
+          <p:cNvPicPr>
+            <a:picLocks noChangeAspect="1"/>
+          </p:cNvPicPr>
+          <p:nvPr/>
+        </p:nvPicPr>
+        <p:blipFill>
+          <a:blip r:embed="rId3"/>
+          <a:stretch>
+            <a:fillRect/>
+          </a:stretch>
+        </p:blipFill>
+        <p:spPr>
+          <a:xfrm>
+            <a:off x="9016093" y="738292"/>
+            <a:ext cx="2395132" cy="5726853"/>
+          </a:xfrm>
+          <a:prstGeom prst="rect">
+            <a:avLst/>
+          </a:prstGeom>
+        </p:spPr>
+      </p:pic>
+    </p:spTree>
+    <p:extLst>
+      <p:ext uri="{BB962C8B-B14F-4D97-AF65-F5344CB8AC3E}">
+        <p14:creationId xmlns:p14="http://schemas.microsoft.com/office/powerpoint/2010/main" val="2584985594"/>
+      </p:ext>
+    </p:extLst>
+  </p:cSld>
+  <p:clrMapOvr>
+    <a:masterClrMapping/>
+  </p:clrMapOvr>
+</p:sld>
+</file>
+
+<file path=ppt/slides/slide6.xml><?xml version="1.0" encoding="utf-8"?>
+<p:sld xmlns:a="http://schemas.openxmlformats.org/drawingml/2006/main" xmlns:r="http://schemas.openxmlformats.org/officeDocument/2006/relationships" xmlns:p="http://schemas.openxmlformats.org/presentationml/2006/main">
+  <p:cSld>
+    <p:spTree>
+      <p:nvGrpSpPr>
+        <p:cNvPr id="1" name=""/>
+        <p:cNvGrpSpPr/>
+        <p:nvPr/>
+      </p:nvGrpSpPr>
+      <p:grpSpPr>
+        <a:xfrm>
+          <a:off x="0" y="0"/>
+          <a:ext cx="0" cy="0"/>
+          <a:chOff x="0" y="0"/>
+          <a:chExt cx="0" cy="0"/>
+        </a:xfrm>
+      </p:grpSpPr>
+      <p:sp>
+        <p:nvSpPr>
+          <p:cNvPr id="2" name="Title 1">
+            <a:extLst>
+              <a:ext uri="{FF2B5EF4-FFF2-40B4-BE49-F238E27FC236}">
+                <a16:creationId xmlns:a16="http://schemas.microsoft.com/office/drawing/2014/main" id="{2A86F5FB-948D-F045-35C9-27AB6C95F896}"/>
+              </a:ext>
+            </a:extLst>
+          </p:cNvPr>
+          <p:cNvSpPr>
+            <a:spLocks noGrp="1"/>
+          </p:cNvSpPr>
+          <p:nvPr>
+            <p:ph type="title"/>
+          </p:nvPr>
+        </p:nvSpPr>
+        <p:spPr/>
+        <p:txBody>
+          <a:bodyPr/>
+          <a:lstStyle/>
+          <a:p>
+            <a:r>
+              <a:rPr lang="en-US" dirty="0"/>
+              <a:t>Future Improvements</a:t>
+            </a:r>
+          </a:p>
+        </p:txBody>
+      </p:sp>
+      <p:sp>
+        <p:nvSpPr>
+          <p:cNvPr id="3" name="Content Placeholder 2">
+            <a:extLst>
+              <a:ext uri="{FF2B5EF4-FFF2-40B4-BE49-F238E27FC236}">
+                <a16:creationId xmlns:a16="http://schemas.microsoft.com/office/drawing/2014/main" id="{438A6DF1-44E1-0E25-E483-E2F2F109BA21}"/>
+              </a:ext>
+            </a:extLst>
+          </p:cNvPr>
+          <p:cNvSpPr>
+            <a:spLocks noGrp="1"/>
+          </p:cNvSpPr>
+          <p:nvPr>
+            <p:ph idx="1"/>
+          </p:nvPr>
+        </p:nvSpPr>
+        <p:spPr/>
+        <p:txBody>
+          <a:bodyPr>
+            <a:normAutofit fontScale="92500" lnSpcReduction="20000"/>
+          </a:bodyPr>
+          <a:lstStyle/>
+          <a:p>
+            <a:r>
+              <a:rPr lang="en-US" dirty="0"/>
+              <a:t>Save and Load Calendar</a:t>
+            </a:r>
+          </a:p>
+          <a:p>
+            <a:r>
+              <a:rPr lang="en-US" dirty="0"/>
+              <a:t>Support Real Calendar Dates and Years</a:t>
+            </a:r>
+          </a:p>
+          <a:p>
+            <a:r>
+              <a:rPr lang="en-US" dirty="0"/>
+              <a:t>Add Recuring Events</a:t>
+            </a:r>
+          </a:p>
+          <a:p>
+            <a:r>
+              <a:rPr lang="en-US" dirty="0"/>
+              <a:t>Add Event Categories</a:t>
+            </a:r>
+          </a:p>
+          <a:p>
+            <a:r>
+              <a:rPr lang="en-US" dirty="0"/>
+              <a:t>Exports schedules to CSV or JSON</a:t>
+            </a:r>
+          </a:p>
+          <a:p>
+            <a:r>
+              <a:rPr lang="en-US" dirty="0"/>
+              <a:t>Improve Time and Display using HH:MM Formatting</a:t>
+            </a:r>
+          </a:p>
+          <a:p>
+            <a:r>
+              <a:rPr lang="en-US" dirty="0"/>
+              <a:t>Utile RealTime such as the Java Date and Time API</a:t>
+            </a:r>
+          </a:p>
+          <a:p>
+            <a:endParaRPr lang="en-US" dirty="0"/>
+          </a:p>
+        </p:txBody>
+      </p:sp>
+    </p:spTree>
+    <p:extLst>
+      <p:ext uri="{BB962C8B-B14F-4D97-AF65-F5344CB8AC3E}">
+        <p14:creationId xmlns:p14="http://schemas.microsoft.com/office/powerpoint/2010/main" val="543831099"/>
+      </p:ext>
+    </p:extLst>
+  </p:cSld>
+  <p:clrMapOvr>
+    <a:masterClrMapping/>
+  </p:clrMapOvr>
+</p:sld>
+</file>
+
+<file path=ppt/slides/slide7.xml><?xml version="1.0" encoding="utf-8"?>
+<p:sld xmlns:a="http://schemas.openxmlformats.org/drawingml/2006/main" xmlns:r="http://schemas.openxmlformats.org/officeDocument/2006/relationships" xmlns:p="http://schemas.openxmlformats.org/presentationml/2006/main">
+  <p:cSld>
+    <p:spTree>
+      <p:nvGrpSpPr>
+        <p:cNvPr id="1" name=""/>
+        <p:cNvGrpSpPr/>
+        <p:nvPr/>
+      </p:nvGrpSpPr>
+      <p:grpSpPr>
+        <a:xfrm>
+          <a:off x="0" y="0"/>
+          <a:ext cx="0" cy="0"/>
+          <a:chOff x="0" y="0"/>
+          <a:chExt cx="0" cy="0"/>
+        </a:xfrm>
+      </p:grpSpPr>
+      <p:sp>
+        <p:nvSpPr>
+          <p:cNvPr id="2" name="Title 1">
+            <a:extLst>
+              <a:ext uri="{FF2B5EF4-FFF2-40B4-BE49-F238E27FC236}">
+                <a16:creationId xmlns:a16="http://schemas.microsoft.com/office/drawing/2014/main" id="{898825E6-F105-1580-0939-3C4D15F4A8F7}"/>
+              </a:ext>
+            </a:extLst>
+          </p:cNvPr>
+          <p:cNvSpPr>
+            <a:spLocks noGrp="1"/>
+          </p:cNvSpPr>
+          <p:nvPr>
+            <p:ph type="title"/>
+          </p:nvPr>
+        </p:nvSpPr>
+        <p:spPr/>
+        <p:txBody>
+          <a:bodyPr/>
+          <a:lstStyle/>
+          <a:p>
+            <a:r>
+              <a:rPr lang="en-US" dirty="0"/>
+              <a:t>Testing</a:t>
+            </a:r>
+          </a:p>
+        </p:txBody>
+      </p:sp>
+      <p:sp>
+        <p:nvSpPr>
+          <p:cNvPr id="6" name="Content Placeholder 5">
+            <a:extLst>
+              <a:ext uri="{FF2B5EF4-FFF2-40B4-BE49-F238E27FC236}">
+                <a16:creationId xmlns:a16="http://schemas.microsoft.com/office/drawing/2014/main" id="{98E8D327-EA99-979B-031F-6A50A6B1F80E}"/>
+              </a:ext>
+            </a:extLst>
+          </p:cNvPr>
+          <p:cNvSpPr>
+            <a:spLocks noGrp="1"/>
+          </p:cNvSpPr>
+          <p:nvPr>
+            <p:ph idx="1"/>
+          </p:nvPr>
+        </p:nvSpPr>
+        <p:spPr/>
+        <p:txBody>
+          <a:bodyPr>
+            <a:normAutofit/>
+          </a:bodyPr>
+          <a:lstStyle/>
+          <a:p>
+            <a:r>
+              <a:rPr lang="en-US" sz="2000" dirty="0"/>
+              <a:t>Test 1: Event Listing — Verify chronological ordering and filtering → PASS </a:t>
+            </a:r>
+          </a:p>
+          <a:p>
+            <a:r>
+              <a:rPr lang="en-US" sz="2000" dirty="0"/>
+              <a:t>Test 2: Event Removal — Verify events are removed and ordering remains intact → PASS </a:t>
+            </a:r>
+          </a:p>
+          <a:p>
+            <a:r>
+              <a:rPr lang="en-US" sz="2000" dirty="0"/>
+              <a:t>Test 3: Conflict Detection — Verify overlapping events are rejected → PASS </a:t>
+            </a:r>
+          </a:p>
+          <a:p>
+            <a:r>
+              <a:rPr lang="en-US" sz="2000" dirty="0"/>
+              <a:t>Test 4: Event Modification — Verify titles and descriptions can be updated → PASS </a:t>
+            </a:r>
+          </a:p>
+          <a:p>
+            <a:pPr>
+              <a:buNone/>
+            </a:pPr>
+            <a:r>
+              <a:rPr lang="en-US" sz="2000" dirty="0"/>
+              <a:t>How to Run Tests:</a:t>
+            </a:r>
+            <a:br>
+              <a:rPr lang="en-US" sz="2000" dirty="0"/>
+            </a:br>
+            <a:r>
+              <a:rPr lang="en-US" sz="2000" dirty="0"/>
+              <a:t>Execute  </a:t>
+            </a:r>
+            <a:r>
+              <a:rPr lang="en-US" sz="1600" b="0" dirty="0">
+                <a:effectLst/>
+                <a:latin typeface="Consolas" panose="020B0609020204030204" pitchFamily="49" charset="0"/>
+              </a:rPr>
+              <a:t>java .\</a:t>
+            </a:r>
+            <a:r>
+              <a:rPr lang="en-US" sz="1600" b="0" dirty="0" err="1">
+                <a:effectLst/>
+                <a:latin typeface="Consolas" panose="020B0609020204030204" pitchFamily="49" charset="0"/>
+              </a:rPr>
+              <a:t>src</a:t>
+            </a:r>
+            <a:r>
+              <a:rPr lang="en-US" sz="1600" b="0" dirty="0">
+                <a:effectLst/>
+                <a:latin typeface="Consolas" panose="020B0609020204030204" pitchFamily="49" charset="0"/>
+              </a:rPr>
+              <a:t>\ Test.java</a:t>
+            </a:r>
+          </a:p>
+        </p:txBody>
+      </p:sp>
+      <p:pic>
+        <p:nvPicPr>
+          <p:cNvPr id="8" name="Picture 7">
+            <a:extLst>
+              <a:ext uri="{FF2B5EF4-FFF2-40B4-BE49-F238E27FC236}">
+                <a16:creationId xmlns:a16="http://schemas.microsoft.com/office/drawing/2014/main" id="{C559A81C-54B0-16A8-10FB-EFAE462B2973}"/>
+              </a:ext>
+            </a:extLst>
+          </p:cNvPr>
+          <p:cNvPicPr>
+            <a:picLocks noChangeAspect="1"/>
+          </p:cNvPicPr>
+          <p:nvPr/>
+        </p:nvPicPr>
+        <p:blipFill>
+          <a:blip r:embed="rId2"/>
+          <a:stretch>
+            <a:fillRect/>
+          </a:stretch>
+        </p:blipFill>
+        <p:spPr>
+          <a:xfrm>
+            <a:off x="6096000" y="4744572"/>
+            <a:ext cx="3784966" cy="2083907"/>
+          </a:xfrm>
+          <a:prstGeom prst="rect">
+            <a:avLst/>
+          </a:prstGeom>
+        </p:spPr>
+      </p:pic>
+      <p:pic>
+        <p:nvPicPr>
+          <p:cNvPr id="10" name="Picture 9">
+            <a:extLst>
+              <a:ext uri="{FF2B5EF4-FFF2-40B4-BE49-F238E27FC236}">
+                <a16:creationId xmlns:a16="http://schemas.microsoft.com/office/drawing/2014/main" id="{3C95CD49-8980-3F10-53C0-4A23CDFB6B0D}"/>
+              </a:ext>
+            </a:extLst>
+          </p:cNvPr>
+          <p:cNvPicPr>
+            <a:picLocks noChangeAspect="1"/>
+          </p:cNvPicPr>
+          <p:nvPr/>
+        </p:nvPicPr>
+        <p:blipFill>
+          <a:blip r:embed="rId3"/>
+          <a:stretch>
+            <a:fillRect/>
+          </a:stretch>
+        </p:blipFill>
+        <p:spPr>
+          <a:xfrm>
+            <a:off x="9956800" y="4744572"/>
+            <a:ext cx="1987115" cy="2079233"/>
+          </a:xfrm>
+          <a:prstGeom prst="rect">
+            <a:avLst/>
+          </a:prstGeom>
+        </p:spPr>
+      </p:pic>
+    </p:spTree>
+    <p:extLst>
+      <p:ext uri="{BB962C8B-B14F-4D97-AF65-F5344CB8AC3E}">
+        <p14:creationId xmlns:p14="http://schemas.microsoft.com/office/powerpoint/2010/main" val="4068203592"/>
+      </p:ext>
+    </p:extLst>
+  </p:cSld>
+  <p:clrMapOvr>
+    <a:masterClrMapping/>
+  </p:clrMapOvr>
+</p:sld>
+</file>
+
+<file path=ppt/slides/slide8.xml><?xml version="1.0" encoding="utf-8"?>
+<p:sld xmlns:a="http://schemas.openxmlformats.org/drawingml/2006/main" xmlns:r="http://schemas.openxmlformats.org/officeDocument/2006/relationships" xmlns:p="http://schemas.openxmlformats.org/presentationml/2006/main">
+  <p:cSld>
+    <p:spTree>
+      <p:nvGrpSpPr>
+        <p:cNvPr id="1" name=""/>
+        <p:cNvGrpSpPr/>
+        <p:nvPr/>
+      </p:nvGrpSpPr>
+      <p:grpSpPr>
+        <a:xfrm>
+          <a:off x="0" y="0"/>
+          <a:ext cx="0" cy="0"/>
+          <a:chOff x="0" y="0"/>
+          <a:chExt cx="0" cy="0"/>
+        </a:xfrm>
+      </p:grpSpPr>
+      <p:sp>
+        <p:nvSpPr>
+          <p:cNvPr id="2" name="Title 1">
+            <a:extLst>
+              <a:ext uri="{FF2B5EF4-FFF2-40B4-BE49-F238E27FC236}">
+                <a16:creationId xmlns:a16="http://schemas.microsoft.com/office/drawing/2014/main" id="{B69C78AB-B908-A80D-CF3A-86D8A0C93CFB}"/>
+              </a:ext>
+            </a:extLst>
+          </p:cNvPr>
+          <p:cNvSpPr>
+            <a:spLocks noGrp="1"/>
+          </p:cNvSpPr>
+          <p:nvPr>
+            <p:ph type="title"/>
+          </p:nvPr>
+        </p:nvSpPr>
+        <p:spPr/>
+        <p:txBody>
+          <a:bodyPr/>
+          <a:lstStyle/>
+          <a:p>
+            <a:r>
+              <a:rPr lang="en-US" dirty="0"/>
+              <a:t>Learning Outcomes</a:t>
+            </a:r>
+          </a:p>
+        </p:txBody>
+      </p:sp>
+      <p:sp>
+        <p:nvSpPr>
+          <p:cNvPr id="3" name="Content Placeholder 2">
+            <a:extLst>
+              <a:ext uri="{FF2B5EF4-FFF2-40B4-BE49-F238E27FC236}">
+                <a16:creationId xmlns:a16="http://schemas.microsoft.com/office/drawing/2014/main" id="{5289DD41-8E56-4B02-8CB7-E8A87C0A08CF}"/>
+              </a:ext>
+            </a:extLst>
+          </p:cNvPr>
+          <p:cNvSpPr>
+            <a:spLocks noGrp="1"/>
+          </p:cNvSpPr>
+          <p:nvPr>
+            <p:ph idx="1"/>
+          </p:nvPr>
+        </p:nvSpPr>
+        <p:spPr/>
+        <p:txBody>
+          <a:bodyPr/>
+          <a:lstStyle/>
+          <a:p>
+            <a:r>
+              <a:rPr lang="en-US" dirty="0"/>
+              <a:t>Object-Oriented Programming principles</a:t>
+            </a:r>
+          </a:p>
+          <a:p>
+            <a:r>
+              <a:rPr lang="en-US" dirty="0"/>
+              <a:t>Data management using custom classes</a:t>
+            </a:r>
+          </a:p>
+          <a:p>
+            <a:r>
+              <a:rPr lang="en-US" dirty="0"/>
+              <a:t>User input handling and validation</a:t>
+            </a:r>
+          </a:p>
+          <a:p>
+            <a:r>
+              <a:rPr lang="en-US" dirty="0"/>
+              <a:t>Event scheduling algorithms</a:t>
+            </a:r>
+          </a:p>
+          <a:p>
+            <a:r>
+              <a:rPr lang="en-US" dirty="0"/>
+              <a:t>Conflict detection and resolution</a:t>
+            </a:r>
+          </a:p>
+          <a:p>
+            <a:r>
+              <a:rPr lang="en-US" dirty="0"/>
+              <a:t>CLI application development in Java</a:t>
+            </a:r>
+          </a:p>
+        </p:txBody>
+      </p:sp>
+    </p:spTree>
+    <p:extLst>
+      <p:ext uri="{BB962C8B-B14F-4D97-AF65-F5344CB8AC3E}">
+        <p14:creationId xmlns:p14="http://schemas.microsoft.com/office/powerpoint/2010/main" val="1925609838"/>
       </p:ext>
     </p:extLst>
   </p:cSld>
@@ -6660,4 +7989,319 @@
     </a:ext>
   </a:extLst>
 </a:theme>
+</file>
+
+<file path=ppt/theme/theme2.xml><?xml version="1.0" encoding="utf-8"?>
+<a:theme xmlns:a="http://schemas.openxmlformats.org/drawingml/2006/main" name="Office Theme">
+  <a:themeElements>
+    <a:clrScheme name="Office">
+      <a:dk1>
+        <a:sysClr val="windowText" lastClr="000000"/>
+      </a:dk1>
+      <a:lt1>
+        <a:sysClr val="window" lastClr="FFFFFF"/>
+      </a:lt1>
+      <a:dk2>
+        <a:srgbClr val="0E2841"/>
+      </a:dk2>
+      <a:lt2>
+        <a:srgbClr val="E8E8E8"/>
+      </a:lt2>
+      <a:accent1>
+        <a:srgbClr val="156082"/>
+      </a:accent1>
+      <a:accent2>
+        <a:srgbClr val="E97132"/>
+      </a:accent2>
+      <a:accent3>
+        <a:srgbClr val="196B24"/>
+      </a:accent3>
+      <a:accent4>
+        <a:srgbClr val="0F9ED5"/>
+      </a:accent4>
+      <a:accent5>
+        <a:srgbClr val="A02B93"/>
+      </a:accent5>
+      <a:accent6>
+        <a:srgbClr val="4EA72E"/>
+      </a:accent6>
+      <a:hlink>
+        <a:srgbClr val="467886"/>
+      </a:hlink>
+      <a:folHlink>
+        <a:srgbClr val="96607D"/>
+      </a:folHlink>
+    </a:clrScheme>
+    <a:fontScheme name="Office">
+      <a:majorFont>
+        <a:latin typeface="Aptos Display" panose="02110004020202020204"/>
+        <a:ea typeface=""/>
+        <a:cs typeface=""/>
+        <a:font script="Jpan" typeface="游ゴシック Light"/>
+        <a:font script="Hang" typeface="맑은 고딕"/>
+        <a:font script="Hans" typeface="等线 Light"/>
+        <a:font script="Hant" typeface="新細明體"/>
+        <a:font script="Arab" typeface="Times New Roman"/>
+        <a:font script="Hebr" typeface="Times New Roman"/>
+        <a:font script="Thai" typeface="Angsana New"/>
+        <a:font script="Ethi" typeface="Nyala"/>
+        <a:font script="Beng" typeface="Vrinda"/>
+        <a:font script="Gujr" typeface="Shruti"/>
+        <a:font script="Khmr" typeface="MoolBoran"/>
+        <a:font script="Knda" typeface="Tunga"/>
+        <a:font script="Guru" typeface="Raavi"/>
+        <a:font script="Cans" typeface="Euphemia"/>
+        <a:font script="Cher" typeface="Plantagenet Cherokee"/>
+        <a:font script="Yiii" typeface="Microsoft Yi Baiti"/>
+        <a:font script="Tibt" typeface="Microsoft Himalaya"/>
+        <a:font script="Thaa" typeface="MV Boli"/>
+        <a:font script="Deva" typeface="Mangal"/>
+        <a:font script="Telu" typeface="Gautami"/>
+        <a:font script="Taml" typeface="Latha"/>
+        <a:font script="Syrc" typeface="Estrangelo Edessa"/>
+        <a:font script="Orya" typeface="Kalinga"/>
+        <a:font script="Mlym" typeface="Kartika"/>
+        <a:font script="Laoo" typeface="DokChampa"/>
+        <a:font script="Sinh" typeface="Iskoola Pota"/>
+        <a:font script="Mong" typeface="Mongolian Baiti"/>
+        <a:font script="Viet" typeface="Times New Roman"/>
+        <a:font script="Uigh" typeface="Microsoft Uighur"/>
+        <a:font script="Geor" typeface="Sylfaen"/>
+        <a:font script="Armn" typeface="Arial"/>
+        <a:font script="Bugi" typeface="Leelawadee UI"/>
+        <a:font script="Bopo" typeface="Microsoft JhengHei"/>
+        <a:font script="Java" typeface="Javanese Text"/>
+        <a:font script="Lisu" typeface="Segoe UI"/>
+        <a:font script="Mymr" typeface="Myanmar Text"/>
+        <a:font script="Nkoo" typeface="Ebrima"/>
+        <a:font script="Olck" typeface="Nirmala UI"/>
+        <a:font script="Osma" typeface="Ebrima"/>
+        <a:font script="Phag" typeface="Phagspa"/>
+        <a:font script="Syrn" typeface="Estrangelo Edessa"/>
+        <a:font script="Syrj" typeface="Estrangelo Edessa"/>
+        <a:font script="Syre" typeface="Estrangelo Edessa"/>
+        <a:font script="Sora" typeface="Nirmala UI"/>
+        <a:font script="Tale" typeface="Microsoft Tai Le"/>
+        <a:font script="Talu" typeface="Microsoft New Tai Lue"/>
+        <a:font script="Tfng" typeface="Ebrima"/>
+      </a:majorFont>
+      <a:minorFont>
+        <a:latin typeface="Aptos" panose="02110004020202020204"/>
+        <a:ea typeface=""/>
+        <a:cs typeface=""/>
+        <a:font script="Jpan" typeface="游ゴシック"/>
+        <a:font script="Hang" typeface="맑은 고딕"/>
+        <a:font script="Hans" typeface="等线"/>
+        <a:font script="Hant" typeface="新細明體"/>
+        <a:font script="Arab" typeface="Arial"/>
+        <a:font script="Hebr" typeface="Arial"/>
+        <a:font script="Thai" typeface="Cordia New"/>
+        <a:font script="Ethi" typeface="Nyala"/>
+        <a:font script="Beng" typeface="Vrinda"/>
+        <a:font script="Gujr" typeface="Shruti"/>
+        <a:font script="Khmr" typeface="DaunPenh"/>
+        <a:font script="Knda" typeface="Tunga"/>
+        <a:font script="Guru" typeface="Raavi"/>
+        <a:font script="Cans" typeface="Euphemia"/>
+        <a:font script="Cher" typeface="Plantagenet Cherokee"/>
+        <a:font script="Yiii" typeface="Microsoft Yi Baiti"/>
+        <a:font script="Tibt" typeface="Microsoft Himalaya"/>
+        <a:font script="Thaa" typeface="MV Boli"/>
+        <a:font script="Deva" typeface="Mangal"/>
+        <a:font script="Telu" typeface="Gautami"/>
+        <a:font script="Taml" typeface="Latha"/>
+        <a:font script="Syrc" typeface="Estrangelo Edessa"/>
+        <a:font script="Orya" typeface="Kalinga"/>
+        <a:font script="Mlym" typeface="Kartika"/>
+        <a:font script="Laoo" typeface="DokChampa"/>
+        <a:font script="Sinh" typeface="Iskoola Pota"/>
+        <a:font script="Mong" typeface="Mongolian Baiti"/>
+        <a:font script="Viet" typeface="Arial"/>
+        <a:font script="Uigh" typeface="Microsoft Uighur"/>
+        <a:font script="Geor" typeface="Sylfaen"/>
+        <a:font script="Armn" typeface="Arial"/>
+        <a:font script="Bugi" typeface="Leelawadee UI"/>
+        <a:font script="Bopo" typeface="Microsoft JhengHei"/>
+        <a:font script="Java" typeface="Javanese Text"/>
+        <a:font script="Lisu" typeface="Segoe UI"/>
+        <a:font script="Mymr" typeface="Myanmar Text"/>
+        <a:font script="Nkoo" typeface="Ebrima"/>
+        <a:font script="Olck" typeface="Nirmala UI"/>
+        <a:font script="Osma" typeface="Ebrima"/>
+        <a:font script="Phag" typeface="Phagspa"/>
+        <a:font script="Syrn" typeface="Estrangelo Edessa"/>
+        <a:font script="Syrj" typeface="Estrangelo Edessa"/>
+        <a:font script="Syre" typeface="Estrangelo Edessa"/>
+        <a:font script="Sora" typeface="Nirmala UI"/>
+        <a:font script="Tale" typeface="Microsoft Tai Le"/>
+        <a:font script="Talu" typeface="Microsoft New Tai Lue"/>
+        <a:font script="Tfng" typeface="Ebrima"/>
+      </a:minorFont>
+    </a:fontScheme>
+    <a:fmtScheme name="Office">
+      <a:fillStyleLst>
+        <a:solidFill>
+          <a:schemeClr val="phClr"/>
+        </a:solidFill>
+        <a:gradFill rotWithShape="1">
+          <a:gsLst>
+            <a:gs pos="0">
+              <a:schemeClr val="phClr">
+                <a:lumMod val="110000"/>
+                <a:satMod val="105000"/>
+                <a:tint val="67000"/>
+              </a:schemeClr>
+            </a:gs>
+            <a:gs pos="50000">
+              <a:schemeClr val="phClr">
+                <a:lumMod val="105000"/>
+                <a:satMod val="103000"/>
+                <a:tint val="73000"/>
+              </a:schemeClr>
+            </a:gs>
+            <a:gs pos="100000">
+              <a:schemeClr val="phClr">
+                <a:lumMod val="105000"/>
+                <a:satMod val="109000"/>
+                <a:tint val="81000"/>
+              </a:schemeClr>
+            </a:gs>
+          </a:gsLst>
+          <a:lin ang="5400000" scaled="0"/>
+        </a:gradFill>
+        <a:gradFill rotWithShape="1">
+          <a:gsLst>
+            <a:gs pos="0">
+              <a:schemeClr val="phClr">
+                <a:satMod val="103000"/>
+                <a:lumMod val="102000"/>
+                <a:tint val="94000"/>
+              </a:schemeClr>
+            </a:gs>
+            <a:gs pos="50000">
+              <a:schemeClr val="phClr">
+                <a:satMod val="110000"/>
+                <a:lumMod val="100000"/>
+                <a:shade val="100000"/>
+              </a:schemeClr>
+            </a:gs>
+            <a:gs pos="100000">
+              <a:schemeClr val="phClr">
+                <a:lumMod val="99000"/>
+                <a:satMod val="120000"/>
+                <a:shade val="78000"/>
+              </a:schemeClr>
+            </a:gs>
+          </a:gsLst>
+          <a:lin ang="5400000" scaled="0"/>
+        </a:gradFill>
+      </a:fillStyleLst>
+      <a:lnStyleLst>
+        <a:ln w="12700" cap="flat" cmpd="sng" algn="ctr">
+          <a:solidFill>
+            <a:schemeClr val="phClr"/>
+          </a:solidFill>
+          <a:prstDash val="solid"/>
+          <a:miter lim="800000"/>
+        </a:ln>
+        <a:ln w="19050" cap="flat" cmpd="sng" algn="ctr">
+          <a:solidFill>
+            <a:schemeClr val="phClr"/>
+          </a:solidFill>
+          <a:prstDash val="solid"/>
+          <a:miter lim="800000"/>
+        </a:ln>
+        <a:ln w="25400" cap="flat" cmpd="sng" algn="ctr">
+          <a:solidFill>
+            <a:schemeClr val="phClr"/>
+          </a:solidFill>
+          <a:prstDash val="solid"/>
+          <a:miter lim="800000"/>
+        </a:ln>
+      </a:lnStyleLst>
+      <a:effectStyleLst>
+        <a:effectStyle>
+          <a:effectLst/>
+        </a:effectStyle>
+        <a:effectStyle>
+          <a:effectLst/>
+        </a:effectStyle>
+        <a:effectStyle>
+          <a:effectLst>
+            <a:outerShdw blurRad="57150" dist="19050" dir="5400000" algn="ctr" rotWithShape="0">
+              <a:srgbClr val="000000">
+                <a:alpha val="63000"/>
+              </a:srgbClr>
+            </a:outerShdw>
+          </a:effectLst>
+        </a:effectStyle>
+      </a:effectStyleLst>
+      <a:bgFillStyleLst>
+        <a:solidFill>
+          <a:schemeClr val="phClr"/>
+        </a:solidFill>
+        <a:solidFill>
+          <a:schemeClr val="phClr">
+            <a:tint val="95000"/>
+            <a:satMod val="170000"/>
+          </a:schemeClr>
+        </a:solidFill>
+        <a:gradFill rotWithShape="1">
+          <a:gsLst>
+            <a:gs pos="0">
+              <a:schemeClr val="phClr">
+                <a:tint val="93000"/>
+                <a:satMod val="150000"/>
+                <a:shade val="98000"/>
+                <a:lumMod val="102000"/>
+              </a:schemeClr>
+            </a:gs>
+            <a:gs pos="50000">
+              <a:schemeClr val="phClr">
+                <a:tint val="98000"/>
+                <a:satMod val="130000"/>
+                <a:shade val="90000"/>
+                <a:lumMod val="103000"/>
+              </a:schemeClr>
+            </a:gs>
+            <a:gs pos="100000">
+              <a:schemeClr val="phClr">
+                <a:shade val="63000"/>
+                <a:satMod val="120000"/>
+              </a:schemeClr>
+            </a:gs>
+          </a:gsLst>
+          <a:lin ang="5400000" scaled="0"/>
+        </a:gradFill>
+      </a:bgFillStyleLst>
+    </a:fmtScheme>
+  </a:themeElements>
+  <a:objectDefaults>
+    <a:lnDef>
+      <a:spPr/>
+      <a:bodyPr/>
+      <a:lstStyle/>
+      <a:style>
+        <a:lnRef idx="2">
+          <a:schemeClr val="accent1"/>
+        </a:lnRef>
+        <a:fillRef idx="0">
+          <a:schemeClr val="accent1"/>
+        </a:fillRef>
+        <a:effectRef idx="1">
+          <a:schemeClr val="accent1"/>
+        </a:effectRef>
+        <a:fontRef idx="minor">
+          <a:schemeClr val="tx1"/>
+        </a:fontRef>
+      </a:style>
+    </a:lnDef>
+  </a:objectDefaults>
+  <a:extraClrSchemeLst/>
+  <a:extLst>
+    <a:ext uri="{05A4C25C-085E-4340-85A3-A5531E510DB2}">
+      <thm15:themeFamily xmlns:thm15="http://schemas.microsoft.com/office/thememl/2012/main" name="Office Theme" id="{2E142A2C-CD16-42D6-873A-C26D2A0506FA}" vid="{1BDDFF52-6CD6-40A5-AB3C-68EB2F1E4D0A}"/>
+    </a:ext>
+  </a:extLst>
+</a:theme>
 </file>
</xml_diff>